<commit_message>
Add live demo URL and repo links
</commit_message>
<xml_diff>
--- a/deck/Paatrata.pptx
+++ b/deck/Paatrata.pptx
@@ -117,37 +117,37 @@
   <p:extLst>
     <p:ext uri="{521415D9-36F7-43E2-AB2F-B90AF26B5E84}">
       <p14:sectionLst xmlns:p14="http://schemas.microsoft.com/office/powerpoint/2010/main">
-        <p14:section name="Opening" id="{20cb314c-92c5-f29b-5436-77eba0da1043}">
+        <p14:section name="Opening" id="{d4e32a99-3dd3-b88e-0344-25bd3aa97d8c}">
           <p14:sldIdLst>
             <p14:sldId id="256"/>
           </p14:sldIdLst>
         </p14:section>
-        <p14:section name="Problem" id="{c20ad8a0-a950-37e6-78cd-a03becf55a94}">
+        <p14:section name="Problem" id="{8e7bebd1-a188-f0de-35ea-ec033a9f684f}">
           <p14:sldIdLst>
             <p14:sldId id="257"/>
             <p14:sldId id="258"/>
           </p14:sldIdLst>
         </p14:section>
-        <p14:section name="Solution" id="{458d924b-9e8c-47c6-e28a-d92df2f56c34}">
+        <p14:section name="Solution" id="{8070ad97-3f9b-5755-b93c-877715aa17ac}">
           <p14:sldIdLst>
             <p14:sldId id="259"/>
             <p14:sldId id="260"/>
             <p14:sldId id="261"/>
           </p14:sldIdLst>
         </p14:section>
-        <p14:section name="Technology" id="{a712d1c6-1ca5-2456-4850-35f8fc5e9028}">
+        <p14:section name="Technology" id="{15668731-da7e-a359-bb3d-87c46fc4e071}">
           <p14:sldIdLst>
             <p14:sldId id="262"/>
             <p14:sldId id="263"/>
           </p14:sldIdLst>
         </p14:section>
-        <p14:section name="Evidence" id="{b17b7490-d2c5-d0d1-37b5-ae43300a8c43}">
+        <p14:section name="Evidence" id="{2ce6b895-e3dc-f008-8508-388cffd49cf4}">
           <p14:sldIdLst>
             <p14:sldId id="264"/>
             <p14:sldId id="265"/>
           </p14:sldIdLst>
         </p14:section>
-        <p14:section name="Close" id="{5d03e090-35b0-c19b-0438-a5e88acd5999}">
+        <p14:section name="Close" id="{ff7edb92-bd4f-03a1-288a-fb9bf5f99ac3}">
           <p14:sldIdLst>
             <p14:sldId id="266"/>
           </p14:sldIdLst>
@@ -3809,7 +3809,7 @@
                 <a:ea typeface="Arial" pitchFamily="34" charset="-122"/>
                 <a:cs typeface="Arial" pitchFamily="34" charset="-120"/>
               </a:rPr>
-              <a:t>Paatrata · पात्रता  |  team clawops  |  github.com/&lt;team&gt;/paatrata  |  Apache-2.0</a:t>
+              <a:t>Live: paatrata.onrender.com  |  github.com/ipshitabhardwaj/Paatrata  |  Apache-2.0  |  team clawops</a:t>
             </a:r>
             <a:endParaRPr lang="en-US" sz="1100" dirty="0"/>
           </a:p>

</xml_diff>